<commit_message>
Move the slide deck to demo/, add the Argo CD GitOps slide and a PDF copy
</commit_message>
<xml_diff>
--- a/demo/DataDrift-Capstone-Presentation.pptx
+++ b/demo/DataDrift-Capstone-Presentation.pptx
@@ -19,6 +19,7 @@
     <p:sldId id="275" r:id="rId26"/>
     <p:sldId id="266" r:id="rId12"/>
     <p:sldId id="267" r:id="rId13"/>
+    <p:sldId id="276" r:id="rId27"/>
     <p:sldId id="268" r:id="rId14"/>
     <p:sldId id="269" r:id="rId15"/>
     <p:sldId id="270" r:id="rId16"/>
@@ -150,6 +151,7 @@
           <p14:sldIdLst>
             <p14:sldId id="266"/>
             <p14:sldId id="267"/>
+            <p14:sldId id="276"/>
             <p14:sldId id="268"/>
             <p14:sldId id="269"/>
             <p14:sldId id="270"/>
@@ -1181,10 +1183,8 @@
           <a:lstStyle/>
           <a:p>
             <a:r>
-              <a:rPr lang="en-US" dirty="0"/>
-              <a:t>Finally, the full loop. I change the version badge in the UI from 1.0.0 to 1.1.0, commit and push. The pipeline starts automatically: tests, build, scan and push, all green. Then I deploy the exact images CI built for this commit with deploy-local --ghcr and the commit SHA. Helm does a rolling update with no downtime, because maxUnavailable is zero. The pods now run the image tagged with the new commit SHA, and the dashboard shows version 1.1.0. If anything went wrong, helm rollback returns to the previous revision.</a:t>
-            </a:r>
-            <a:endParaRPr lang="en-US" dirty="0"/>
+              <a:t>Finally, the full loop. I change the version badge in the UI from 1.0.0 to 1.1.0, commit and push. The pipeline runs tests, build, Trivy scan and push, and its last job commits the new commit SHA into values-gitops.yaml. Argo CD checks Git every minute, sees the new tag and does a rolling update with no downtime, because maxUnavailable is zero. The pods now run the image tagged with the new commit SHA, and the dashboard shows the new version. To roll back, I revert that commit in Git and Argo CD puts the previous image back.</a:t>
+            </a:r>
           </a:p>
         </p:txBody>
       </p:sp>
@@ -1628,6 +1628,76 @@
 </p:notes>
 </file>
 
+<file path=ppt/notesSlides/notesSlide21.xml><?xml version="1.0" encoding="utf-8"?>
+<p:notes xmlns:a="http://schemas.openxmlformats.org/drawingml/2006/main" xmlns:p="http://schemas.openxmlformats.org/presentationml/2006/main" xmlns:r="http://schemas.openxmlformats.org/officeDocument/2006/relationships">
+  <p:cSld>
+    <p:spTree>
+      <p:nvGrpSpPr>
+        <p:cNvPr id="1" name=""/>
+        <p:cNvGrpSpPr/>
+        <p:nvPr/>
+      </p:nvGrpSpPr>
+      <p:grpSpPr>
+        <a:xfrm>
+          <a:off x="0" y="0"/>
+          <a:ext cx="0" cy="0"/>
+          <a:chOff x="0" y="0"/>
+          <a:chExt cx="0" cy="0"/>
+        </a:xfrm>
+      </p:grpSpPr>
+      <p:sp>
+        <p:nvSpPr>
+          <p:cNvPr id="2" name="Slide Image Placeholder 1"/>
+          <p:cNvSpPr>
+            <a:spLocks noGrp="1"/>
+          </p:cNvSpPr>
+          <p:nvPr>
+            <p:ph type="sldImg" idx="2"/>
+          </p:nvPr>
+        </p:nvSpPr>
+        <p:spPr/>
+      </p:sp>
+      <p:sp>
+        <p:nvSpPr>
+          <p:cNvPr id="3" name="Notes Placeholder 2"/>
+          <p:cNvSpPr>
+            <a:spLocks noGrp="1"/>
+          </p:cNvSpPr>
+          <p:nvPr>
+            <p:ph type="body" idx="3" sz="quarter"/>
+          </p:nvPr>
+        </p:nvSpPr>
+        <p:spPr/>
+        <p:txBody>
+          <a:bodyPr/>
+          <a:lstStyle/>
+          <a:p>
+            <a:r>
+              <a:t>Deployment is GitOps with Argo CD. Argo CD runs inside the cluster and watches this repository. The Application manifest points it at the Helm chart and a values file, values-gitops.yaml, which holds the image tags. The pipeline never talks to the cluster: its last job commits the new commit SHA into that file. Argo CD checks Git every minute, sees the new tag and syncs. Sync is automated with prune and self-heal, so if someone edits the cluster by hand Argo CD puts it back to what Git says. Rolling back is just reverting the tag commit.</a:t>
+            </a:r>
+          </a:p>
+        </p:txBody>
+      </p:sp>
+      <p:sp>
+        <p:nvSpPr>
+          <p:cNvPr id="4" name="Slide Number Placeholder 3"/>
+          <p:cNvSpPr>
+            <a:spLocks noGrp="1"/>
+          </p:cNvSpPr>
+          <p:nvPr>
+            <p:ph type="sldNum" idx="5" sz="quarter"/>
+          </p:nvPr>
+        </p:nvSpPr>
+        <p:spPr/>
+      </p:sp>
+    </p:spTree>
+  </p:cSld>
+  <p:clrMapOvr>
+    <a:masterClrMapping/>
+  </p:clrMapOvr>
+</p:notes>
+</file>
+
 <file path=ppt/notesSlides/notesSlide3.xml><?xml version="1.0" encoding="utf-8"?>
 <p:notes xmlns:a="http://schemas.openxmlformats.org/drawingml/2006/main" xmlns:r="http://schemas.openxmlformats.org/officeDocument/2006/relationships" xmlns:p="http://schemas.openxmlformats.org/presentationml/2006/main">
   <p:cSld>
@@ -1673,10 +1743,8 @@
           <a:lstStyle/>
           <a:p>
             <a:r>
-              <a:rPr lang="en-US" dirty="0"/>
-              <a:t>Here's the architecture. When I push to GitHub, GitHub Actions runs the tests, builds both Docker images, scans them with Trivy and pushes them to the GitHub Container Registry, tagged with the commit SHA. Helm deploys those images into Kubernetes: kind on my laptop, or EKS on AWS, which Terraform describes. The Ingress sends slash to the React frontend and slash api to the FastAPI backend, which stores data in PostgreSQL. Prometheus scrapes the backend's metrics every 15 seconds, and Grafana shows the dashboard and the drift alert.</a:t>
-            </a:r>
-            <a:endParaRPr lang="en-US" dirty="0"/>
+              <a:t>Here's the architecture. When I push to GitHub, GitHub Actions runs the tests, builds both Docker images, scans them with Trivy and pushes them to the GitHub Container Registry, tagged with the commit SHA. CI then writes the new tag into the Helm values in Git, and Argo CD deploys it into Kubernetes: kind on my laptop, or EKS on AWS, which Terraform describes. The Ingress sends slash to the React frontend and slash api to the FastAPI backend, which stores data in PostgreSQL. Prometheus scrapes the backend's metrics every 15 seconds, and Grafana shows the dashboard and the drift alert.</a:t>
+            </a:r>
           </a:p>
         </p:txBody>
       </p:sp>
@@ -2201,10 +2269,8 @@
           <a:lstStyle/>
           <a:p>
             <a:r>
-              <a:rPr lang="en-US" dirty="0"/>
-              <a:t>This is the GitHub Actions pipeline. It runs on every push and pull request to main. Three jobs run in parallel: backend lint and tests, the frontend build, and validation of the Terraform and Helm code. Only if all three pass do we build the images. The build job runs once for the backend and once for the frontend: build, Trivy scan, then push to the GitHub Container Registry. The images are tagged with the full Git commit SHA, never latest. The last job deploys with Helm when a cluster is configured through a kubeconfig secret.</a:t>
-            </a:r>
-            <a:endParaRPr lang="en-US" dirty="0"/>
+              <a:t>This is the GitHub Actions pipeline. It runs on every push and pull request to main. Three jobs run in parallel: backend lint and tests, the frontend build, and validation of the Terraform and Helm code. Only if all three pass do we build the images. The build job runs once for the backend and once for the frontend: build, Trivy scan, then push to the GitHub Container Registry. The images are tagged with the full Git commit SHA, never latest. The last job is the GitOps hand-off: it commits the new SHA into the Helm values file in Git, and Argo CD in the cluster picks that up and deploys it. The pipeline itself never touches the cluster.</a:t>
+            </a:r>
           </a:p>
         </p:txBody>
       </p:sp>
@@ -4468,6 +4534,369 @@
 </file>
 
 <file path=ppt/slides/slide12.xml><?xml version="1.0" encoding="utf-8"?>
+<p:sld xmlns:a="http://schemas.openxmlformats.org/drawingml/2006/main" xmlns:p="http://schemas.openxmlformats.org/presentationml/2006/main" xmlns:r="http://schemas.openxmlformats.org/officeDocument/2006/relationships">
+  <p:cSld>
+    <p:spTree>
+      <p:nvGrpSpPr>
+        <p:cNvPr id="1" name=""/>
+        <p:cNvGrpSpPr/>
+        <p:nvPr/>
+      </p:nvGrpSpPr>
+      <p:grpSpPr/>
+      <p:sp>
+        <p:nvSpPr>
+          <p:cNvPr id="3" name="Text 0"/>
+          <p:cNvSpPr/>
+          <p:nvPr>
+            <p:ph idx="101" type="title" hasCustomPrompt="1"/>
+          </p:nvPr>
+        </p:nvSpPr>
+        <p:spPr>
+          <a:xfrm>
+            <a:off x="548640" y="621792"/>
+            <a:ext cx="11064240" cy="731520"/>
+          </a:xfrm>
+          <a:prstGeom prst="rect">
+            <a:avLst/>
+          </a:prstGeom>
+          <a:noFill/>
+          <a:ln/>
+        </p:spPr>
+        <p:txBody>
+          <a:bodyPr wrap="square" lIns="0" tIns="0" rIns="0" bIns="0" rtlCol="0" anchor="t"/>
+          <a:lstStyle/>
+          <a:p>
+            <a:pPr algn="l" indent="0" marL="0">
+              <a:buNone/>
+            </a:pPr>
+            <a:r>
+              <a:rPr lang="en-US" sz="3400" b="1" dirty="0">
+                <a:solidFill>
+                  <a:schemeClr val="tx1"/>
+                </a:solidFill>
+              </a:rPr>
+              <a:t>Every image is tagged with its commit</a:t>
+            </a:r>
+            <a:endParaRPr lang="en-US" sz="3400" dirty="0"/>
+          </a:p>
+        </p:txBody>
+      </p:sp>
+      <p:sp>
+        <p:nvSpPr>
+          <p:cNvPr id="2" name="Text 0"/>
+          <p:cNvSpPr/>
+          <p:nvPr>
+            <p:ph idx="100" type="body" hasCustomPrompt="1"/>
+          </p:nvPr>
+        </p:nvSpPr>
+        <p:spPr>
+          <a:xfrm>
+            <a:off x="548640" y="320040"/>
+            <a:ext cx="8229600" cy="292608"/>
+          </a:xfrm>
+          <a:prstGeom prst="rect">
+            <a:avLst/>
+          </a:prstGeom>
+          <a:noFill/>
+          <a:ln/>
+        </p:spPr>
+        <p:txBody>
+          <a:bodyPr wrap="square" lIns="0" tIns="0" rIns="0" bIns="0" rtlCol="0"/>
+          <a:lstStyle/>
+          <a:p>
+            <a:pPr indent="0" marL="0">
+              <a:buNone/>
+            </a:pPr>
+            <a:r>
+              <a:rPr lang="en-US" sz="1200" b="1" spc="200" kern="0" dirty="0">
+                <a:solidFill>
+                  <a:schemeClr val="accent1"/>
+                </a:solidFill>
+              </a:rPr>
+              <a:t>M5 · CONTAINER REGISTRY</a:t>
+            </a:r>
+            <a:endParaRPr lang="en-US" sz="1200" dirty="0"/>
+          </a:p>
+        </p:txBody>
+      </p:sp>
+      <p:sp>
+        <p:nvSpPr>
+          <p:cNvPr id="25" name="Slide Number Placeholder 0"/>
+          <p:cNvSpPr>
+            <a:spLocks noGrp="1"/>
+          </p:cNvSpPr>
+          <p:nvPr>
+            <p:ph type="sldNum" sz="quarter" idx="4294967295"/>
+          </p:nvPr>
+        </p:nvSpPr>
+        <p:spPr>
+          <a:xfrm>
+            <a:off x="11183112" y="6473952"/>
+            <a:ext cx="457200" cy="274320"/>
+          </a:xfrm>
+          <a:prstGeom prst="rect">
+            <a:avLst/>
+          </a:prstGeom>
+          <a:extLst>
+            <a:ext uri="{C572A759-6A51-4108-AA02-DFA0A04FC94B}">
+              <ma14:wrappingTextBoxFlag xmlns:ma14="http://schemas.microsoft.com/office/mac/drawingml/2011/main" val="0"/>
+            </a:ext>
+          </a:extLst>
+        </p:spPr>
+        <p:txBody>
+          <a:bodyPr lIns="0" tIns="0" rIns="0" bIns="0"/>
+          <a:lstStyle>
+            <a:lvl1pPr>
+              <a:defRPr sz="1000">
+                <a:solidFill>
+                  <a:srgbClr val="64748B"/>
+                </a:solidFill>
+              </a:defRPr>
+            </a:lvl1pPr>
+          </a:lstStyle>
+          <a:p>
+            <a:pPr algn="r"/>
+            <a:fld id="{F7021451-1387-4CA6-816F-3879F97B5CBC}" type="slidenum">
+              <a:rPr b="0" lang="en-US"/>
+              <a:t>10</a:t>
+            </a:fld>
+            <a:endParaRPr lang="en-US"/>
+          </a:p>
+        </p:txBody>
+      </p:sp>
+      <p:sp>
+        <p:nvSpPr>
+          <p:cNvPr id="22" name="card 36-ghcr-backend-package.png"/>
+          <p:cNvSpPr/>
+          <p:nvPr/>
+        </p:nvSpPr>
+        <p:spPr>
+          <a:xfrm>
+            <a:off x="548640" y="1645920"/>
+            <a:ext cx="5541264" cy="3375398"/>
+          </a:xfrm>
+          <a:prstGeom prst="roundRect">
+            <a:avLst>
+              <a:gd name="adj" fmla="val 2039"/>
+            </a:avLst>
+          </a:prstGeom>
+          <a:solidFill>
+            <a:schemeClr val="bg1"/>
+          </a:solidFill>
+          <a:ln w="9525">
+            <a:solidFill>
+              <a:srgbClr val="E0E7FF"/>
+            </a:solidFill>
+            <a:prstDash val="solid"/>
+          </a:ln>
+          <a:effectLst>
+            <a:outerShdw sx="100000" sy="100000" kx="0" ky="0" algn="bl" rotWithShape="0" blurRad="127000" dist="38100" dir="5400000">
+              <a:srgbClr val="1E1B4B">
+                <a:alpha val="18000"/>
+              </a:srgbClr>
+            </a:outerShdw>
+          </a:effectLst>
+        </p:spPr>
+      </p:sp>
+      <p:sp>
+        <p:nvSpPr>
+          <p:cNvPr id="24" name="caption 36-ghcr-backend-package.png"/>
+          <p:cNvSpPr txBox="1"/>
+          <p:nvPr/>
+        </p:nvSpPr>
+        <p:spPr>
+          <a:xfrm>
+            <a:off x="548640" y="5076182"/>
+            <a:ext cx="5541264" cy="256032"/>
+          </a:xfrm>
+          <a:prstGeom prst="rect">
+            <a:avLst/>
+          </a:prstGeom>
+          <a:noFill/>
+          <a:ln/>
+        </p:spPr>
+        <p:txBody>
+          <a:bodyPr wrap="square" lIns="0" tIns="0" rIns="0" bIns="0" rtlCol="0" anchor="ctr"/>
+          <a:lstStyle/>
+          <a:p>
+            <a:pPr algn="ctr" indent="0" marL="0">
+              <a:buNone/>
+            </a:pPr>
+            <a:r>
+              <a:rPr lang="en-US" sz="1100" i="1" dirty="0">
+                <a:solidFill>
+                  <a:schemeClr val="accent6"/>
+                </a:solidFill>
+              </a:rPr>
+              <a:t>ghcr.io/kavyadhyani/datadrift-backend: one tag per commit SHA</a:t>
+            </a:r>
+            <a:endParaRPr lang="en-US" sz="1100" dirty="0"/>
+          </a:p>
+        </p:txBody>
+      </p:sp>
+      <p:sp>
+        <p:nvSpPr>
+          <p:cNvPr id="22" name="card 37-ghcr-frontend-package.png"/>
+          <p:cNvSpPr/>
+          <p:nvPr/>
+        </p:nvSpPr>
+        <p:spPr>
+          <a:xfrm>
+            <a:off x="6101791" y="1645920"/>
+            <a:ext cx="5541264" cy="3378223"/>
+          </a:xfrm>
+          <a:prstGeom prst="roundRect">
+            <a:avLst>
+              <a:gd name="adj" fmla="val 2039"/>
+            </a:avLst>
+          </a:prstGeom>
+          <a:solidFill>
+            <a:schemeClr val="bg1"/>
+          </a:solidFill>
+          <a:ln w="9525">
+            <a:solidFill>
+              <a:srgbClr val="E0E7FF"/>
+            </a:solidFill>
+            <a:prstDash val="solid"/>
+          </a:ln>
+          <a:effectLst>
+            <a:outerShdw sx="100000" sy="100000" kx="0" ky="0" algn="bl" rotWithShape="0" blurRad="127000" dist="38100" dir="5400000">
+              <a:srgbClr val="1E1B4B">
+                <a:alpha val="18000"/>
+              </a:srgbClr>
+            </a:outerShdw>
+          </a:effectLst>
+        </p:spPr>
+      </p:sp>
+      <p:sp>
+        <p:nvSpPr>
+          <p:cNvPr id="24" name="caption 37-ghcr-frontend-package.png"/>
+          <p:cNvSpPr txBox="1"/>
+          <p:nvPr/>
+        </p:nvSpPr>
+        <p:spPr>
+          <a:xfrm>
+            <a:off x="6101791" y="5079007"/>
+            <a:ext cx="5541264" cy="256032"/>
+          </a:xfrm>
+          <a:prstGeom prst="rect">
+            <a:avLst/>
+          </a:prstGeom>
+          <a:noFill/>
+          <a:ln/>
+        </p:spPr>
+        <p:txBody>
+          <a:bodyPr wrap="square" lIns="0" tIns="0" rIns="0" bIns="0" rtlCol="0" anchor="ctr"/>
+          <a:lstStyle/>
+          <a:p>
+            <a:pPr algn="ctr" indent="0" marL="0">
+              <a:buNone/>
+            </a:pPr>
+            <a:r>
+              <a:rPr lang="en-US" sz="1100" i="1" dirty="0">
+                <a:solidFill>
+                  <a:schemeClr val="accent6"/>
+                </a:solidFill>
+              </a:rPr>
+              <a:t>ghcr.io/kavyadhyani/datadrift-frontend: the same SHAs</a:t>
+            </a:r>
+            <a:endParaRPr lang="en-US" sz="1100" dirty="0"/>
+          </a:p>
+        </p:txBody>
+      </p:sp>
+      <p:sp>
+        <p:nvSpPr>
+          <p:cNvPr id="21" name="pipeline note"/>
+          <p:cNvSpPr txBox="1"/>
+          <p:nvPr/>
+        </p:nvSpPr>
+        <p:spPr>
+          <a:xfrm>
+            <a:off x="548640" y="5623560"/>
+            <a:ext cx="11091672" cy="548640"/>
+          </a:xfrm>
+          <a:prstGeom prst="rect">
+            <a:avLst/>
+          </a:prstGeom>
+          <a:noFill/>
+          <a:ln/>
+        </p:spPr>
+        <p:txBody>
+          <a:bodyPr wrap="square" lIns="0" tIns="0" rIns="0" bIns="0" rtlCol="0" anchor="t"/>
+          <a:lstStyle/>
+          <a:p>
+            <a:pPr indent="0" marL="0">
+              <a:buNone/>
+            </a:pPr>
+            <a:r>
+              <a:rPr lang="en-US" sz="1400" dirty="0">
+                <a:solidFill>
+                  <a:schemeClr val="tx2"/>
+                </a:solidFill>
+              </a:rPr>
+              <a:t>Both packages are public, so the cluster pulls them anonymously. A running pod’s image tag points straight back to the commit that built it, and no image is ever tagged latest.</a:t>
+            </a:r>
+            <a:endParaRPr lang="en-US" sz="1400" dirty="0"/>
+          </a:p>
+        </p:txBody>
+      </p:sp>
+      <p:pic>
+        <p:nvPicPr>
+          <p:cNvPr id="26" name="36-ghcr-backend-package.png" descr="36-ghcr-backend-package.png"/>
+          <p:cNvPicPr>
+            <a:picLocks noChangeAspect="1"/>
+          </p:cNvPicPr>
+          <p:nvPr/>
+        </p:nvPicPr>
+        <p:blipFill>
+          <a:blip r:embed="rId2"/>
+          <a:stretch>
+            <a:fillRect/>
+          </a:stretch>
+        </p:blipFill>
+        <p:spPr>
+          <a:xfrm>
+            <a:off x="612647" y="1709928"/>
+            <a:ext cx="5413248" cy="3247382"/>
+          </a:xfrm>
+          <a:prstGeom prst="rect">
+            <a:avLst/>
+          </a:prstGeom>
+        </p:spPr>
+      </p:pic>
+      <p:pic>
+        <p:nvPicPr>
+          <p:cNvPr id="27" name="37-ghcr-frontend-package.png" descr="37-ghcr-frontend-package.png"/>
+          <p:cNvPicPr>
+            <a:picLocks noChangeAspect="1"/>
+          </p:cNvPicPr>
+          <p:nvPr/>
+        </p:nvPicPr>
+        <p:blipFill>
+          <a:blip r:embed="rId3"/>
+          <a:stretch>
+            <a:fillRect/>
+          </a:stretch>
+        </p:blipFill>
+        <p:spPr>
+          <a:xfrm>
+            <a:off x="6165799" y="1709928"/>
+            <a:ext cx="5413248" cy="3250207"/>
+          </a:xfrm>
+          <a:prstGeom prst="rect">
+            <a:avLst/>
+          </a:prstGeom>
+        </p:spPr>
+      </p:pic>
+    </p:spTree>
+  </p:cSld>
+  <p:clrMapOvr>
+    <a:masterClrMapping/>
+  </p:clrMapOvr>
+</p:sld>
+</file>
+
+<file path=ppt/slides/slide13.xml><?xml version="1.0" encoding="utf-8"?>
 <p:sld xmlns:a="http://schemas.openxmlformats.org/drawingml/2006/main" xmlns:r="http://schemas.openxmlformats.org/officeDocument/2006/relationships" xmlns:p="http://schemas.openxmlformats.org/presentationml/2006/main">
   <p:cSld name="Slide 11">
     <p:spTree>
@@ -5200,7 +5629,7 @@
 </p:sld>
 </file>
 
-<file path=ppt/slides/slide13.xml><?xml version="1.0" encoding="utf-8"?>
+<file path=ppt/slides/slide14.xml><?xml version="1.0" encoding="utf-8"?>
 <p:sld xmlns:a="http://schemas.openxmlformats.org/drawingml/2006/main" xmlns:r="http://schemas.openxmlformats.org/officeDocument/2006/relationships" xmlns:p="http://schemas.openxmlformats.org/presentationml/2006/main">
   <p:cSld name="Slide 12">
     <p:spTree>
@@ -6018,7 +6447,7 @@
 </p:sld>
 </file>
 
-<file path=ppt/slides/slide14.xml><?xml version="1.0" encoding="utf-8"?>
+<file path=ppt/slides/slide15.xml><?xml version="1.0" encoding="utf-8"?>
 <p:sld xmlns:a="http://schemas.openxmlformats.org/drawingml/2006/main" xmlns:r="http://schemas.openxmlformats.org/officeDocument/2006/relationships" xmlns:p="http://schemas.openxmlformats.org/presentationml/2006/main">
   <p:cSld name="Slide 13">
     <p:spTree>
@@ -6144,6 +6573,10 @@
             </a:outerShdw>
           </a:effectLst>
         </p:spPr>
+        <p:txBody>
+          <a:bodyPr/>
+          <a:p/>
+        </p:txBody>
       </p:sp>
       <p:pic>
         <p:nvPicPr>
@@ -6238,6 +6671,10 @@
             </a:outerShdw>
           </a:effectLst>
         </p:spPr>
+        <p:txBody>
+          <a:bodyPr/>
+          <a:p/>
+        </p:txBody>
       </p:sp>
       <p:pic>
         <p:nvPicPr>
@@ -6323,6 +6760,10 @@
             <a:prstDash val="solid"/>
           </a:ln>
         </p:spPr>
+        <p:txBody>
+          <a:bodyPr/>
+          <a:p/>
+        </p:txBody>
       </p:sp>
       <p:pic>
         <p:nvPicPr>
@@ -6444,6 +6885,10 @@
             <a:prstDash val="solid"/>
           </a:ln>
         </p:spPr>
+        <p:txBody>
+          <a:bodyPr/>
+          <a:p/>
+        </p:txBody>
       </p:sp>
       <p:pic>
         <p:nvPicPr>
@@ -6565,6 +7010,10 @@
             <a:prstDash val="solid"/>
           </a:ln>
         </p:spPr>
+        <p:txBody>
+          <a:bodyPr/>
+          <a:p/>
+        </p:txBody>
       </p:sp>
       <p:pic>
         <p:nvPicPr>
@@ -6715,7 +7164,7 @@
 </p:sld>
 </file>
 
-<file path=ppt/slides/slide15.xml><?xml version="1.0" encoding="utf-8"?>
+<file path=ppt/slides/slide16.xml><?xml version="1.0" encoding="utf-8"?>
 <p:sld xmlns:a="http://schemas.openxmlformats.org/drawingml/2006/main" xmlns:r="http://schemas.openxmlformats.org/officeDocument/2006/relationships" xmlns:p="http://schemas.openxmlformats.org/presentationml/2006/main">
   <p:cSld name="Slide 14">
     <p:spTree>
@@ -7457,7 +7906,7 @@
 </p:sld>
 </file>
 
-<file path=ppt/slides/slide16.xml><?xml version="1.0" encoding="utf-8"?>
+<file path=ppt/slides/slide17.xml><?xml version="1.0" encoding="utf-8"?>
 <p:sld xmlns:a="http://schemas.openxmlformats.org/drawingml/2006/main" xmlns:r="http://schemas.openxmlformats.org/officeDocument/2006/relationships" xmlns:p="http://schemas.openxmlformats.org/presentationml/2006/main">
   <p:cSld name="Slide 15">
     <p:spTree>
@@ -8097,7 +8546,7 @@
 </p:sld>
 </file>
 
-<file path=ppt/slides/slide17.xml><?xml version="1.0" encoding="utf-8"?>
+<file path=ppt/slides/slide18.xml><?xml version="1.0" encoding="utf-8"?>
 <p:sld xmlns:a="http://schemas.openxmlformats.org/drawingml/2006/main" xmlns:r="http://schemas.openxmlformats.org/officeDocument/2006/relationships" xmlns:p="http://schemas.openxmlformats.org/presentationml/2006/main">
   <p:cSld name="Slide 16">
     <p:spTree>
@@ -8146,7 +8595,7 @@
                   <a:schemeClr val="accent1"/>
                 </a:solidFill>
               </a:rPr>
-              <a:t>M10 · LIVE CHANGE · 5 PTS</a:t>
+              <a:t>LIVE CHANGE · CI/CD + GITOPS</a:t>
             </a:r>
             <a:endParaRPr lang="en-US" sz="1200" dirty="0"/>
           </a:p>
@@ -8223,6 +8672,10 @@
             </a:outerShdw>
           </a:effectLst>
         </p:spPr>
+        <p:txBody>
+          <a:bodyPr/>
+          <a:p/>
+        </p:txBody>
       </p:sp>
       <p:sp>
         <p:nvSpPr>
@@ -8297,6 +8750,10 @@
             <a:tailEnd type="triangle"/>
           </a:ln>
         </p:spPr>
+        <p:txBody>
+          <a:bodyPr/>
+          <a:p/>
+        </p:txBody>
       </p:sp>
       <p:sp>
         <p:nvSpPr>
@@ -8331,6 +8788,10 @@
             </a:outerShdw>
           </a:effectLst>
         </p:spPr>
+        <p:txBody>
+          <a:bodyPr/>
+          <a:p/>
+        </p:txBody>
       </p:sp>
       <p:sp>
         <p:nvSpPr>
@@ -8405,6 +8866,10 @@
             <a:tailEnd type="triangle"/>
           </a:ln>
         </p:spPr>
+        <p:txBody>
+          <a:bodyPr/>
+          <a:p/>
+        </p:txBody>
       </p:sp>
       <p:sp>
         <p:nvSpPr>
@@ -8439,6 +8904,10 @@
             </a:outerShdw>
           </a:effectLst>
         </p:spPr>
+        <p:txBody>
+          <a:bodyPr/>
+          <a:p/>
+        </p:txBody>
       </p:sp>
       <p:sp>
         <p:nvSpPr>
@@ -8484,7 +8953,7 @@
                   <a:schemeClr val="bg1"/>
                 </a:solidFill>
               </a:rPr>
-              <a:t>images pushed to GHCR</a:t>
+              <a:t>image + tag commit</a:t>
             </a:r>
             <a:endParaRPr lang="en-US" sz="1500" dirty="0"/>
           </a:p>
@@ -8513,6 +8982,10 @@
             <a:tailEnd type="triangle"/>
           </a:ln>
         </p:spPr>
+        <p:txBody>
+          <a:bodyPr/>
+          <a:p/>
+        </p:txBody>
       </p:sp>
       <p:sp>
         <p:nvSpPr>
@@ -8547,6 +9020,10 @@
             </a:outerShdw>
           </a:effectLst>
         </p:spPr>
+        <p:txBody>
+          <a:bodyPr/>
+          <a:p/>
+        </p:txBody>
       </p:sp>
       <p:sp>
         <p:nvSpPr>
@@ -8578,7 +9055,7 @@
                   <a:schemeClr val="bg1"/>
                 </a:solidFill>
               </a:rPr>
-              <a:t>deploy --ghcr</a:t>
+              <a:t>Argo CD sync</a:t>
             </a:r>
             <a:endParaRPr lang="en-US" sz="1500" dirty="0"/>
           </a:p>
@@ -8592,7 +9069,7 @@
                   <a:schemeClr val="bg1"/>
                 </a:solidFill>
               </a:rPr>
-              <a:t>helm rolling update</a:t>
+              <a:t>rolling update</a:t>
             </a:r>
             <a:endParaRPr lang="en-US" sz="1500" dirty="0"/>
           </a:p>
@@ -8621,6 +9098,10 @@
             <a:tailEnd type="triangle"/>
           </a:ln>
         </p:spPr>
+        <p:txBody>
+          <a:bodyPr/>
+          <a:p/>
+        </p:txBody>
       </p:sp>
       <p:sp>
         <p:nvSpPr>
@@ -8655,6 +9136,10 @@
             </a:outerShdw>
           </a:effectLst>
         </p:spPr>
+        <p:txBody>
+          <a:bodyPr/>
+          <a:p/>
+        </p:txBody>
       </p:sp>
       <p:sp>
         <p:nvSpPr>
@@ -8739,6 +9224,10 @@
             </a:outerShdw>
           </a:effectLst>
         </p:spPr>
+        <p:txBody>
+          <a:bodyPr/>
+          <a:p/>
+        </p:txBody>
       </p:sp>
       <p:pic>
         <p:nvPicPr>
@@ -8797,6 +9286,10 @@
             </a:outerShdw>
           </a:effectLst>
         </p:spPr>
+        <p:txBody>
+          <a:bodyPr/>
+          <a:p/>
+        </p:txBody>
       </p:sp>
       <p:pic>
         <p:nvPicPr>
@@ -8888,7 +9381,7 @@
                   <a:schemeClr val="tx2"/>
                 </a:solidFill>
               </a:rPr>
-              <a:t>Both Deployments now run </a:t>
+              <a:t>Both Deployments run the image CI built for that commit, tagged with its SHA.</a:t>
             </a:r>
             <a:pPr indent="0" marL="0">
               <a:buNone/>
@@ -8899,7 +9392,7 @@
                   <a:schemeClr val="accent1"/>
                 </a:solidFill>
               </a:rPr>
-              <a:t>ghcr.io/kavyadhyani/…:3198bd6…</a:t>
+              <a:t/>
             </a:r>
             <a:pPr indent="0" marL="0">
               <a:buNone/>
@@ -8910,7 +9403,7 @@
                   <a:schemeClr val="tx2"/>
                 </a:solidFill>
               </a:rPr>
-              <a:t>, the image CI built for that commit.</a:t>
+              <a:t/>
             </a:r>
             <a:endParaRPr lang="en-US" sz="1400" dirty="0"/>
           </a:p>
@@ -8938,7 +9431,7 @@
                   <a:schemeClr val="tx2"/>
                 </a:solidFill>
               </a:rPr>
-              <a:t>maxUnavailable: 0 keeps the app up during the rollout; helm rollback returns to any earlier revision.</a:t>
+              <a:t>Argo CD rolls it out with maxUnavailable: 0, so the app stays up; reverting the tag commit in Git rolls it back.</a:t>
             </a:r>
             <a:endParaRPr lang="en-US" sz="1400" dirty="0"/>
           </a:p>
@@ -8997,7 +9490,7 @@
 </p:sld>
 </file>
 
-<file path=ppt/slides/slide18.xml><?xml version="1.0" encoding="utf-8"?>
+<file path=ppt/slides/slide19.xml><?xml version="1.0" encoding="utf-8"?>
 <p:sld xmlns:a="http://schemas.openxmlformats.org/drawingml/2006/main" xmlns:r="http://schemas.openxmlformats.org/officeDocument/2006/relationships" xmlns:p="http://schemas.openxmlformats.org/presentationml/2006/main">
   <p:cSld name="Slide 17">
     <p:spTree>
@@ -9724,70 +10217,6 @@
               <a:t>17</a:t>
             </a:fld>
             <a:endParaRPr lang="en-US"/>
-          </a:p>
-        </p:txBody>
-      </p:sp>
-    </p:spTree>
-  </p:cSld>
-  <p:clrMapOvr>
-    <a:masterClrMapping/>
-  </p:clrMapOvr>
-</p:sld>
-</file>
-
-<file path=ppt/slides/slide19.xml><?xml version="1.0" encoding="utf-8"?>
-<p:sld xmlns:a="http://schemas.openxmlformats.org/drawingml/2006/main" xmlns:r="http://schemas.openxmlformats.org/officeDocument/2006/relationships" xmlns:p="http://schemas.openxmlformats.org/presentationml/2006/main">
-  <p:cSld name="Slide 18">
-    <p:spTree>
-      <p:nvGrpSpPr>
-        <p:cNvPr id="1" name=""/>
-        <p:cNvGrpSpPr/>
-        <p:nvPr/>
-      </p:nvGrpSpPr>
-      <p:grpSpPr>
-        <a:xfrm>
-          <a:off x="0" y="0"/>
-          <a:ext cx="0" cy="0"/>
-          <a:chOff x="0" y="0"/>
-          <a:chExt cx="0" cy="0"/>
-        </a:xfrm>
-      </p:grpSpPr>
-      <p:sp>
-        <p:nvSpPr>
-          <p:cNvPr id="2" name="thank you"/>
-          <p:cNvSpPr txBox="1"/>
-          <p:nvPr/>
-        </p:nvSpPr>
-        <p:spPr>
-          <a:xfrm>
-            <a:off x="548640" y="2331720"/>
-            <a:ext cx="11091672" cy="2194560"/>
-          </a:xfrm>
-          <a:prstGeom prst="rect">
-            <a:avLst/>
-          </a:prstGeom>
-          <a:noFill/>
-          <a:ln/>
-        </p:spPr>
-        <p:txBody>
-          <a:bodyPr wrap="square" lIns="0" tIns="0" rIns="0" bIns="0" rtlCol="0" anchor="ctr"/>
-          <a:lstStyle/>
-          <a:p>
-            <a:pPr algn="ctr" indent="0" marL="0">
-              <a:buNone/>
-            </a:pPr>
-            <a:r>
-              <a:rPr lang="en-US" sz="12000" b="1" dirty="0">
-                <a:solidFill>
-                  <a:schemeClr val="bg1"/>
-                </a:solidFill>
-                <a:latin typeface="Arial" pitchFamily="34" charset="0"/>
-                <a:ea typeface="Arial" pitchFamily="34" charset="-122"/>
-                <a:cs typeface="Arial" pitchFamily="34" charset="-120"/>
-              </a:rPr>
-              <a:t>Thank you</a:t>
-            </a:r>
-            <a:endParaRPr lang="en-US" sz="12000" dirty="0"/>
           </a:p>
         </p:txBody>
       </p:sp>
@@ -10598,6 +11027,70 @@
 </file>
 
 <file path=ppt/slides/slide20.xml><?xml version="1.0" encoding="utf-8"?>
+<p:sld xmlns:a="http://schemas.openxmlformats.org/drawingml/2006/main" xmlns:r="http://schemas.openxmlformats.org/officeDocument/2006/relationships" xmlns:p="http://schemas.openxmlformats.org/presentationml/2006/main">
+  <p:cSld name="Slide 18">
+    <p:spTree>
+      <p:nvGrpSpPr>
+        <p:cNvPr id="1" name=""/>
+        <p:cNvGrpSpPr/>
+        <p:nvPr/>
+      </p:nvGrpSpPr>
+      <p:grpSpPr>
+        <a:xfrm>
+          <a:off x="0" y="0"/>
+          <a:ext cx="0" cy="0"/>
+          <a:chOff x="0" y="0"/>
+          <a:chExt cx="0" cy="0"/>
+        </a:xfrm>
+      </p:grpSpPr>
+      <p:sp>
+        <p:nvSpPr>
+          <p:cNvPr id="2" name="thank you"/>
+          <p:cNvSpPr txBox="1"/>
+          <p:nvPr/>
+        </p:nvSpPr>
+        <p:spPr>
+          <a:xfrm>
+            <a:off x="548640" y="2331720"/>
+            <a:ext cx="11091672" cy="2194560"/>
+          </a:xfrm>
+          <a:prstGeom prst="rect">
+            <a:avLst/>
+          </a:prstGeom>
+          <a:noFill/>
+          <a:ln/>
+        </p:spPr>
+        <p:txBody>
+          <a:bodyPr wrap="square" lIns="0" tIns="0" rIns="0" bIns="0" rtlCol="0" anchor="ctr"/>
+          <a:lstStyle/>
+          <a:p>
+            <a:pPr algn="ctr" indent="0" marL="0">
+              <a:buNone/>
+            </a:pPr>
+            <a:r>
+              <a:rPr lang="en-US" sz="12000" b="1" dirty="0">
+                <a:solidFill>
+                  <a:schemeClr val="bg1"/>
+                </a:solidFill>
+                <a:latin typeface="Arial" pitchFamily="34" charset="0"/>
+                <a:ea typeface="Arial" pitchFamily="34" charset="-122"/>
+                <a:cs typeface="Arial" pitchFamily="34" charset="-120"/>
+              </a:rPr>
+              <a:t>Thank you</a:t>
+            </a:r>
+            <a:endParaRPr lang="en-US" sz="12000" dirty="0"/>
+          </a:p>
+        </p:txBody>
+      </p:sp>
+    </p:spTree>
+  </p:cSld>
+  <p:clrMapOvr>
+    <a:masterClrMapping/>
+  </p:clrMapOvr>
+</p:sld>
+</file>
+
+<file path=ppt/slides/slide21.xml><?xml version="1.0" encoding="utf-8"?>
 <p:sld xmlns:a="http://schemas.openxmlformats.org/drawingml/2006/main" xmlns:p="http://schemas.openxmlformats.org/presentationml/2006/main" xmlns:r="http://schemas.openxmlformats.org/officeDocument/2006/relationships">
   <p:cSld>
     <p:spTree>
@@ -10609,6 +11102,44 @@
       <p:grpSpPr/>
       <p:sp>
         <p:nvSpPr>
+          <p:cNvPr id="2" name="Text 0"/>
+          <p:cNvSpPr/>
+          <p:nvPr>
+            <p:ph idx="100" type="body" hasCustomPrompt="1"/>
+          </p:nvPr>
+        </p:nvSpPr>
+        <p:spPr>
+          <a:xfrm>
+            <a:off x="548640" y="320040"/>
+            <a:ext cx="8229600" cy="292608"/>
+          </a:xfrm>
+          <a:prstGeom prst="rect">
+            <a:avLst/>
+          </a:prstGeom>
+          <a:noFill/>
+          <a:ln/>
+        </p:spPr>
+        <p:txBody>
+          <a:bodyPr wrap="square" lIns="0" tIns="0" rIns="0" bIns="0" rtlCol="0"/>
+          <a:lstStyle/>
+          <a:p>
+            <a:pPr indent="0" marL="0">
+              <a:buNone/>
+            </a:pPr>
+            <a:r>
+              <a:rPr lang="en-US" sz="1200" b="1" spc="200" kern="0" dirty="0">
+                <a:solidFill>
+                  <a:schemeClr val="accent1"/>
+                </a:solidFill>
+              </a:rPr>
+              <a:t>M8 · GITOPS WITH ARGO CD</a:t>
+            </a:r>
+            <a:endParaRPr lang="en-US" sz="1200" dirty="0"/>
+          </a:p>
+        </p:txBody>
+      </p:sp>
+      <p:sp>
+        <p:nvSpPr>
           <p:cNvPr id="3" name="Text 0"/>
           <p:cNvSpPr/>
           <p:nvPr>
@@ -10639,47 +11170,9 @@
                   <a:schemeClr val="tx1"/>
                 </a:solidFill>
               </a:rPr>
-              <a:t>Every image is tagged with its commit</a:t>
+              <a:t>Git decides what runs in the cluster</a:t>
             </a:r>
             <a:endParaRPr lang="en-US" sz="3400" dirty="0"/>
-          </a:p>
-        </p:txBody>
-      </p:sp>
-      <p:sp>
-        <p:nvSpPr>
-          <p:cNvPr id="2" name="Text 0"/>
-          <p:cNvSpPr/>
-          <p:nvPr>
-            <p:ph idx="100" type="body" hasCustomPrompt="1"/>
-          </p:nvPr>
-        </p:nvSpPr>
-        <p:spPr>
-          <a:xfrm>
-            <a:off x="548640" y="320040"/>
-            <a:ext cx="8229600" cy="292608"/>
-          </a:xfrm>
-          <a:prstGeom prst="rect">
-            <a:avLst/>
-          </a:prstGeom>
-          <a:noFill/>
-          <a:ln/>
-        </p:spPr>
-        <p:txBody>
-          <a:bodyPr wrap="square" lIns="0" tIns="0" rIns="0" bIns="0" rtlCol="0"/>
-          <a:lstStyle/>
-          <a:p>
-            <a:pPr indent="0" marL="0">
-              <a:buNone/>
-            </a:pPr>
-            <a:r>
-              <a:rPr lang="en-US" sz="1200" b="1" spc="200" kern="0" dirty="0">
-                <a:solidFill>
-                  <a:schemeClr val="accent1"/>
-                </a:solidFill>
-              </a:rPr>
-              <a:t>M5 · CONTAINER REGISTRY</a:t>
-            </a:r>
-            <a:endParaRPr lang="en-US" sz="1200" dirty="0"/>
           </a:p>
         </p:txBody>
       </p:sp>
@@ -10722,7 +11215,7 @@
             <a:pPr algn="r"/>
             <a:fld id="{F7021451-1387-4CA6-816F-3879F97B5CBC}" type="slidenum">
               <a:rPr b="0" lang="en-US"/>
-              <a:t>10</a:t>
+              <a:t>12</a:t>
             </a:fld>
             <a:endParaRPr lang="en-US"/>
           </a:p>
@@ -10730,26 +11223,26 @@
       </p:sp>
       <p:sp>
         <p:nvSpPr>
-          <p:cNvPr id="22" name="card 36-ghcr-backend-package.png"/>
+          <p:cNvPr id="4" name="live Edit"/>
           <p:cNvSpPr/>
           <p:nvPr/>
         </p:nvSpPr>
         <p:spPr>
           <a:xfrm>
-            <a:off x="548640" y="1645920"/>
-            <a:ext cx="5541264" cy="3375398"/>
+            <a:off x="548640" y="1600200"/>
+            <a:ext cx="2011680" cy="868680"/>
           </a:xfrm>
           <a:prstGeom prst="roundRect">
             <a:avLst>
-              <a:gd name="adj" fmla="val 2039"/>
+              <a:gd name="adj" fmla="val 10526"/>
             </a:avLst>
           </a:prstGeom>
           <a:solidFill>
-            <a:schemeClr val="bg1"/>
+            <a:schemeClr val="tx1"/>
           </a:solidFill>
-          <a:ln w="9525">
+          <a:ln w="12700">
             <a:solidFill>
-              <a:srgbClr val="E0E7FF"/>
+              <a:schemeClr val="tx1"/>
             </a:solidFill>
             <a:prstDash val="solid"/>
           </a:ln>
@@ -10761,17 +11254,21 @@
             </a:outerShdw>
           </a:effectLst>
         </p:spPr>
-      </p:sp>
-      <p:sp>
-        <p:nvSpPr>
-          <p:cNvPr id="24" name="caption 36-ghcr-backend-package.png"/>
+        <p:txBody>
+          <a:bodyPr/>
+          <a:p/>
+        </p:txBody>
+      </p:sp>
+      <p:sp>
+        <p:nvSpPr>
+          <p:cNvPr id="5" name="Text 3"/>
           <p:cNvSpPr txBox="1"/>
           <p:nvPr/>
         </p:nvSpPr>
         <p:spPr>
           <a:xfrm>
-            <a:off x="548640" y="5076182"/>
-            <a:ext cx="5541264" cy="256032"/>
+            <a:off x="640080" y="1600200"/>
+            <a:ext cx="1828800" cy="868680"/>
           </a:xfrm>
           <a:prstGeom prst="rect">
             <a:avLst/>
@@ -10787,39 +11284,81 @@
               <a:buNone/>
             </a:pPr>
             <a:r>
-              <a:rPr lang="en-US" sz="1100" i="1" dirty="0">
-                <a:solidFill>
-                  <a:schemeClr val="accent6"/>
-                </a:solidFill>
-              </a:rPr>
-              <a:t>ghcr.io/kavyadhyani/datadrift-backend: one tag per commit SHA</a:t>
-            </a:r>
-            <a:endParaRPr lang="en-US" sz="1100" dirty="0"/>
-          </a:p>
-        </p:txBody>
-      </p:sp>
-      <p:sp>
-        <p:nvSpPr>
-          <p:cNvPr id="22" name="card 37-ghcr-frontend-package.png"/>
+              <a:rPr lang="en-US" sz="1500" b="1" dirty="0">
+                <a:solidFill>
+                  <a:schemeClr val="bg1"/>
+                </a:solidFill>
+              </a:rPr>
+              <a:t>git push</a:t>
+            </a:r>
+            <a:endParaRPr lang="en-US" sz="1500" dirty="0"/>
+          </a:p>
+          <a:p>
+            <a:pPr algn="ctr" indent="0" marL="0">
+              <a:buNone/>
+            </a:pPr>
+            <a:r>
+              <a:rPr lang="en-US" sz="1200" dirty="0">
+                <a:solidFill>
+                  <a:schemeClr val="bg1"/>
+                </a:solidFill>
+              </a:rPr>
+              <a:t>code change</a:t>
+            </a:r>
+            <a:endParaRPr lang="en-US" sz="1500" dirty="0"/>
+          </a:p>
+        </p:txBody>
+      </p:sp>
+      <p:sp>
+        <p:nvSpPr>
+          <p:cNvPr id="6" name="live arrow 0"/>
           <p:cNvSpPr/>
           <p:nvPr/>
         </p:nvSpPr>
         <p:spPr>
           <a:xfrm>
-            <a:off x="6101791" y="1645920"/>
-            <a:ext cx="5541264" cy="3378223"/>
+            <a:off x="2587752" y="2029968"/>
+            <a:ext cx="201168" cy="0"/>
+          </a:xfrm>
+          <a:prstGeom prst="line">
+            <a:avLst/>
+          </a:prstGeom>
+          <a:noFill/>
+          <a:ln w="22225">
+            <a:solidFill>
+              <a:srgbClr val="64748B"/>
+            </a:solidFill>
+            <a:prstDash val="solid"/>
+            <a:tailEnd type="triangle"/>
+          </a:ln>
+        </p:spPr>
+        <p:txBody>
+          <a:bodyPr/>
+          <a:p/>
+        </p:txBody>
+      </p:sp>
+      <p:sp>
+        <p:nvSpPr>
+          <p:cNvPr id="7" name="live git push"/>
+          <p:cNvSpPr/>
+          <p:nvPr/>
+        </p:nvSpPr>
+        <p:spPr>
+          <a:xfrm>
+            <a:off x="2816352" y="1600200"/>
+            <a:ext cx="2011680" cy="868680"/>
           </a:xfrm>
           <a:prstGeom prst="roundRect">
             <a:avLst>
-              <a:gd name="adj" fmla="val 2039"/>
+              <a:gd name="adj" fmla="val 10526"/>
             </a:avLst>
           </a:prstGeom>
           <a:solidFill>
-            <a:schemeClr val="bg1"/>
+            <a:schemeClr val="tx1"/>
           </a:solidFill>
-          <a:ln w="9525">
+          <a:ln w="12700">
             <a:solidFill>
-              <a:srgbClr val="E0E7FF"/>
+              <a:schemeClr val="tx1"/>
             </a:solidFill>
             <a:prstDash val="solid"/>
           </a:ln>
@@ -10831,17 +11370,21 @@
             </a:outerShdw>
           </a:effectLst>
         </p:spPr>
-      </p:sp>
-      <p:sp>
-        <p:nvSpPr>
-          <p:cNvPr id="24" name="caption 37-ghcr-frontend-package.png"/>
+        <p:txBody>
+          <a:bodyPr/>
+          <a:p/>
+        </p:txBody>
+      </p:sp>
+      <p:sp>
+        <p:nvSpPr>
+          <p:cNvPr id="8" name="Text 6"/>
           <p:cNvSpPr txBox="1"/>
           <p:nvPr/>
         </p:nvSpPr>
         <p:spPr>
           <a:xfrm>
-            <a:off x="6101791" y="5079007"/>
-            <a:ext cx="5541264" cy="256032"/>
+            <a:off x="2907792" y="1600200"/>
+            <a:ext cx="1828800" cy="868680"/>
           </a:xfrm>
           <a:prstGeom prst="rect">
             <a:avLst/>
@@ -10857,27 +11400,418 @@
               <a:buNone/>
             </a:pPr>
             <a:r>
-              <a:rPr lang="en-US" sz="1100" i="1" dirty="0">
-                <a:solidFill>
-                  <a:schemeClr val="accent6"/>
-                </a:solidFill>
-              </a:rPr>
-              <a:t>ghcr.io/kavyadhyani/datadrift-frontend: the same SHAs</a:t>
-            </a:r>
-            <a:endParaRPr lang="en-US" sz="1100" dirty="0"/>
-          </a:p>
-        </p:txBody>
-      </p:sp>
-      <p:sp>
-        <p:nvSpPr>
-          <p:cNvPr id="21" name="pipeline note"/>
+              <a:rPr lang="en-US" sz="1500" b="1" dirty="0">
+                <a:solidFill>
+                  <a:schemeClr val="bg1"/>
+                </a:solidFill>
+              </a:rPr>
+              <a:t>CI</a:t>
+            </a:r>
+            <a:endParaRPr lang="en-US" sz="1500" dirty="0"/>
+          </a:p>
+          <a:p>
+            <a:pPr algn="ctr" indent="0" marL="0">
+              <a:buNone/>
+            </a:pPr>
+            <a:r>
+              <a:rPr lang="en-US" sz="1200" dirty="0">
+                <a:solidFill>
+                  <a:schemeClr val="bg1"/>
+                </a:solidFill>
+              </a:rPr>
+              <a:t>test · scan · push</a:t>
+            </a:r>
+            <a:endParaRPr lang="en-US" sz="1500" dirty="0"/>
+          </a:p>
+        </p:txBody>
+      </p:sp>
+      <p:sp>
+        <p:nvSpPr>
+          <p:cNvPr id="9" name="live arrow 1"/>
+          <p:cNvSpPr/>
+          <p:nvPr/>
+        </p:nvSpPr>
+        <p:spPr>
+          <a:xfrm>
+            <a:off x="4855464" y="2029968"/>
+            <a:ext cx="201168" cy="0"/>
+          </a:xfrm>
+          <a:prstGeom prst="line">
+            <a:avLst/>
+          </a:prstGeom>
+          <a:noFill/>
+          <a:ln w="22225">
+            <a:solidFill>
+              <a:srgbClr val="64748B"/>
+            </a:solidFill>
+            <a:prstDash val="solid"/>
+            <a:tailEnd type="triangle"/>
+          </a:ln>
+        </p:spPr>
+        <p:txBody>
+          <a:bodyPr/>
+          <a:p/>
+        </p:txBody>
+      </p:sp>
+      <p:sp>
+        <p:nvSpPr>
+          <p:cNvPr id="10" name="live CI green"/>
+          <p:cNvSpPr/>
+          <p:nvPr/>
+        </p:nvSpPr>
+        <p:spPr>
+          <a:xfrm>
+            <a:off x="5084064" y="1600200"/>
+            <a:ext cx="2011680" cy="868680"/>
+          </a:xfrm>
+          <a:prstGeom prst="roundRect">
+            <a:avLst>
+              <a:gd name="adj" fmla="val 10526"/>
+            </a:avLst>
+          </a:prstGeom>
+          <a:solidFill>
+            <a:schemeClr val="tx1"/>
+          </a:solidFill>
+          <a:ln w="12700">
+            <a:solidFill>
+              <a:schemeClr val="tx1"/>
+            </a:solidFill>
+            <a:prstDash val="solid"/>
+          </a:ln>
+          <a:effectLst>
+            <a:outerShdw sx="100000" sy="100000" kx="0" ky="0" algn="bl" rotWithShape="0" blurRad="127000" dist="38100" dir="5400000">
+              <a:srgbClr val="1E1B4B">
+                <a:alpha val="18000"/>
+              </a:srgbClr>
+            </a:outerShdw>
+          </a:effectLst>
+        </p:spPr>
+        <p:txBody>
+          <a:bodyPr/>
+          <a:p/>
+        </p:txBody>
+      </p:sp>
+      <p:sp>
+        <p:nvSpPr>
+          <p:cNvPr id="11" name="Text 9"/>
           <p:cNvSpPr txBox="1"/>
           <p:nvPr/>
         </p:nvSpPr>
         <p:spPr>
           <a:xfrm>
-            <a:off x="548640" y="5623560"/>
-            <a:ext cx="11091672" cy="548640"/>
+            <a:off x="5175504" y="1600200"/>
+            <a:ext cx="1828800" cy="868680"/>
+          </a:xfrm>
+          <a:prstGeom prst="rect">
+            <a:avLst/>
+          </a:prstGeom>
+          <a:noFill/>
+          <a:ln/>
+        </p:spPr>
+        <p:txBody>
+          <a:bodyPr wrap="square" lIns="0" tIns="0" rIns="0" bIns="0" rtlCol="0" anchor="ctr"/>
+          <a:lstStyle/>
+          <a:p>
+            <a:pPr algn="ctr" indent="0" marL="0">
+              <a:buNone/>
+            </a:pPr>
+            <a:r>
+              <a:rPr lang="en-US" sz="1500" b="1" dirty="0">
+                <a:solidFill>
+                  <a:schemeClr val="bg1"/>
+                </a:solidFill>
+              </a:rPr>
+              <a:t>Tag commit</a:t>
+            </a:r>
+            <a:endParaRPr lang="en-US" sz="1500" dirty="0"/>
+          </a:p>
+          <a:p>
+            <a:pPr algn="ctr" indent="0" marL="0">
+              <a:buNone/>
+            </a:pPr>
+            <a:r>
+              <a:rPr lang="en-US" sz="1200" dirty="0">
+                <a:solidFill>
+                  <a:schemeClr val="bg1"/>
+                </a:solidFill>
+              </a:rPr>
+              <a:t>values-gitops.yaml</a:t>
+            </a:r>
+            <a:endParaRPr lang="en-US" sz="1500" dirty="0"/>
+          </a:p>
+        </p:txBody>
+      </p:sp>
+      <p:sp>
+        <p:nvSpPr>
+          <p:cNvPr id="12" name="live arrow 2"/>
+          <p:cNvSpPr/>
+          <p:nvPr/>
+        </p:nvSpPr>
+        <p:spPr>
+          <a:xfrm>
+            <a:off x="7123176" y="2029968"/>
+            <a:ext cx="201168" cy="0"/>
+          </a:xfrm>
+          <a:prstGeom prst="line">
+            <a:avLst/>
+          </a:prstGeom>
+          <a:noFill/>
+          <a:ln w="22225">
+            <a:solidFill>
+              <a:srgbClr val="64748B"/>
+            </a:solidFill>
+            <a:prstDash val="solid"/>
+            <a:tailEnd type="triangle"/>
+          </a:ln>
+        </p:spPr>
+        <p:txBody>
+          <a:bodyPr/>
+          <a:p/>
+        </p:txBody>
+      </p:sp>
+      <p:sp>
+        <p:nvSpPr>
+          <p:cNvPr id="13" name="live deploy --ghcr"/>
+          <p:cNvSpPr/>
+          <p:nvPr/>
+        </p:nvSpPr>
+        <p:spPr>
+          <a:xfrm>
+            <a:off x="7351776" y="1600200"/>
+            <a:ext cx="2011680" cy="868680"/>
+          </a:xfrm>
+          <a:prstGeom prst="roundRect">
+            <a:avLst>
+              <a:gd name="adj" fmla="val 10526"/>
+            </a:avLst>
+          </a:prstGeom>
+          <a:solidFill>
+            <a:schemeClr val="tx1"/>
+          </a:solidFill>
+          <a:ln w="12700">
+            <a:solidFill>
+              <a:schemeClr val="tx1"/>
+            </a:solidFill>
+            <a:prstDash val="solid"/>
+          </a:ln>
+          <a:effectLst>
+            <a:outerShdw sx="100000" sy="100000" kx="0" ky="0" algn="bl" rotWithShape="0" blurRad="127000" dist="38100" dir="5400000">
+              <a:srgbClr val="1E1B4B">
+                <a:alpha val="18000"/>
+              </a:srgbClr>
+            </a:outerShdw>
+          </a:effectLst>
+        </p:spPr>
+        <p:txBody>
+          <a:bodyPr/>
+          <a:p/>
+        </p:txBody>
+      </p:sp>
+      <p:sp>
+        <p:nvSpPr>
+          <p:cNvPr id="14" name="Text 12"/>
+          <p:cNvSpPr txBox="1"/>
+          <p:nvPr/>
+        </p:nvSpPr>
+        <p:spPr>
+          <a:xfrm>
+            <a:off x="7443216" y="1600200"/>
+            <a:ext cx="1828800" cy="868680"/>
+          </a:xfrm>
+          <a:prstGeom prst="rect">
+            <a:avLst/>
+          </a:prstGeom>
+          <a:noFill/>
+          <a:ln/>
+        </p:spPr>
+        <p:txBody>
+          <a:bodyPr wrap="square" lIns="0" tIns="0" rIns="0" bIns="0" rtlCol="0" anchor="ctr"/>
+          <a:lstStyle/>
+          <a:p>
+            <a:pPr algn="ctr" indent="0" marL="0">
+              <a:buNone/>
+            </a:pPr>
+            <a:r>
+              <a:rPr lang="en-US" sz="1500" b="1" dirty="0">
+                <a:solidFill>
+                  <a:schemeClr val="bg1"/>
+                </a:solidFill>
+              </a:rPr>
+              <a:t>Argo CD</a:t>
+            </a:r>
+            <a:endParaRPr lang="en-US" sz="1500" dirty="0"/>
+          </a:p>
+          <a:p>
+            <a:pPr algn="ctr" indent="0" marL="0">
+              <a:buNone/>
+            </a:pPr>
+            <a:r>
+              <a:rPr lang="en-US" sz="1200" dirty="0">
+                <a:solidFill>
+                  <a:schemeClr val="bg1"/>
+                </a:solidFill>
+              </a:rPr>
+              <a:t>sees it within 1 min</a:t>
+            </a:r>
+            <a:endParaRPr lang="en-US" sz="1500" dirty="0"/>
+          </a:p>
+        </p:txBody>
+      </p:sp>
+      <p:sp>
+        <p:nvSpPr>
+          <p:cNvPr id="15" name="live arrow 3"/>
+          <p:cNvSpPr/>
+          <p:nvPr/>
+        </p:nvSpPr>
+        <p:spPr>
+          <a:xfrm>
+            <a:off x="9390888" y="2029968"/>
+            <a:ext cx="201168" cy="0"/>
+          </a:xfrm>
+          <a:prstGeom prst="line">
+            <a:avLst/>
+          </a:prstGeom>
+          <a:noFill/>
+          <a:ln w="22225">
+            <a:solidFill>
+              <a:srgbClr val="64748B"/>
+            </a:solidFill>
+            <a:prstDash val="solid"/>
+            <a:tailEnd type="triangle"/>
+          </a:ln>
+        </p:spPr>
+        <p:txBody>
+          <a:bodyPr/>
+          <a:p/>
+        </p:txBody>
+      </p:sp>
+      <p:sp>
+        <p:nvSpPr>
+          <p:cNvPr id="16" name="live Live"/>
+          <p:cNvSpPr/>
+          <p:nvPr/>
+        </p:nvSpPr>
+        <p:spPr>
+          <a:xfrm>
+            <a:off x="9619488" y="1600200"/>
+            <a:ext cx="2011680" cy="868680"/>
+          </a:xfrm>
+          <a:prstGeom prst="roundRect">
+            <a:avLst>
+              <a:gd name="adj" fmla="val 10526"/>
+            </a:avLst>
+          </a:prstGeom>
+          <a:solidFill>
+            <a:schemeClr val="accent3"/>
+          </a:solidFill>
+          <a:ln w="12700">
+            <a:solidFill>
+              <a:schemeClr val="accent3"/>
+            </a:solidFill>
+            <a:prstDash val="solid"/>
+          </a:ln>
+          <a:effectLst>
+            <a:outerShdw sx="100000" sy="100000" kx="0" ky="0" algn="bl" rotWithShape="0" blurRad="127000" dist="38100" dir="5400000">
+              <a:srgbClr val="1E1B4B">
+                <a:alpha val="18000"/>
+              </a:srgbClr>
+            </a:outerShdw>
+          </a:effectLst>
+        </p:spPr>
+        <p:txBody>
+          <a:bodyPr/>
+          <a:p/>
+        </p:txBody>
+      </p:sp>
+      <p:sp>
+        <p:nvSpPr>
+          <p:cNvPr id="17" name="Text 15"/>
+          <p:cNvSpPr txBox="1"/>
+          <p:nvPr/>
+        </p:nvSpPr>
+        <p:spPr>
+          <a:xfrm>
+            <a:off x="9710928" y="1600200"/>
+            <a:ext cx="1828800" cy="868680"/>
+          </a:xfrm>
+          <a:prstGeom prst="rect">
+            <a:avLst/>
+          </a:prstGeom>
+          <a:noFill/>
+          <a:ln/>
+        </p:spPr>
+        <p:txBody>
+          <a:bodyPr wrap="square" lIns="0" tIns="0" rIns="0" bIns="0" rtlCol="0" anchor="ctr"/>
+          <a:lstStyle/>
+          <a:p>
+            <a:pPr algn="ctr" indent="0" marL="0">
+              <a:buNone/>
+            </a:pPr>
+            <a:r>
+              <a:rPr lang="en-US" sz="1500" b="1" dirty="0">
+                <a:solidFill>
+                  <a:schemeClr val="bg1"/>
+                </a:solidFill>
+              </a:rPr>
+              <a:t>Cluster</a:t>
+            </a:r>
+            <a:endParaRPr lang="en-US" sz="1500" dirty="0"/>
+          </a:p>
+          <a:p>
+            <a:pPr algn="ctr" indent="0" marL="0">
+              <a:buNone/>
+            </a:pPr>
+            <a:r>
+              <a:rPr lang="en-US" sz="1200" dirty="0">
+                <a:solidFill>
+                  <a:schemeClr val="bg1"/>
+                </a:solidFill>
+              </a:rPr>
+              <a:t>rolling update</a:t>
+            </a:r>
+            <a:endParaRPr lang="en-US" sz="1500" dirty="0"/>
+          </a:p>
+        </p:txBody>
+      </p:sp>
+      <p:sp>
+        <p:nvSpPr>
+          <p:cNvPr id="26" name="icon circle Tagged with the commit SHA"/>
+          <p:cNvSpPr/>
+          <p:nvPr/>
+        </p:nvSpPr>
+        <p:spPr>
+          <a:xfrm>
+            <a:off x="548640" y="2926080"/>
+            <a:ext cx="512064" cy="512064"/>
+          </a:xfrm>
+          <a:prstGeom prst="ellipse">
+            <a:avLst/>
+          </a:prstGeom>
+          <a:solidFill>
+            <a:schemeClr val="accent1"/>
+          </a:solidFill>
+          <a:ln w="12700">
+            <a:solidFill>
+              <a:schemeClr val="accent1"/>
+            </a:solidFill>
+            <a:prstDash val="solid"/>
+          </a:ln>
+        </p:spPr>
+        <p:txBody>
+          <a:bodyPr/>
+          <a:p/>
+        </p:txBody>
+      </p:sp>
+      <p:sp>
+        <p:nvSpPr>
+          <p:cNvPr id="28" name="Text 24"/>
+          <p:cNvSpPr txBox="1"/>
+          <p:nvPr/>
+        </p:nvSpPr>
+        <p:spPr>
+          <a:xfrm>
+            <a:off x="1261872" y="2907792"/>
+            <a:ext cx="5047488" cy="329184"/>
           </a:xfrm>
           <a:prstGeom prst="rect">
             <a:avLst/>
@@ -10893,12 +11827,48 @@
               <a:buNone/>
             </a:pPr>
             <a:r>
+              <a:rPr lang="en-US" sz="1700" b="1" dirty="0">
+                <a:solidFill>
+                  <a:schemeClr val="tx1"/>
+                </a:solidFill>
+              </a:rPr>
+              <a:t>Application = chart + values</a:t>
+            </a:r>
+            <a:endParaRPr lang="en-US" sz="1700" dirty="0"/>
+          </a:p>
+        </p:txBody>
+      </p:sp>
+      <p:sp>
+        <p:nvSpPr>
+          <p:cNvPr id="29" name="Text 25"/>
+          <p:cNvSpPr txBox="1"/>
+          <p:nvPr/>
+        </p:nvSpPr>
+        <p:spPr>
+          <a:xfrm>
+            <a:off x="1261872" y="3255264"/>
+            <a:ext cx="5047488" cy="749808"/>
+          </a:xfrm>
+          <a:prstGeom prst="rect">
+            <a:avLst/>
+          </a:prstGeom>
+          <a:noFill/>
+          <a:ln/>
+        </p:spPr>
+        <p:txBody>
+          <a:bodyPr wrap="square" lIns="0" tIns="0" rIns="0" bIns="0" rtlCol="0" anchor="t"/>
+          <a:lstStyle/>
+          <a:p>
+            <a:pPr indent="0" marL="0">
+              <a:buNone/>
+            </a:pPr>
+            <a:r>
               <a:rPr lang="en-US" sz="1400" dirty="0">
                 <a:solidFill>
                   <a:schemeClr val="tx2"/>
                 </a:solidFill>
               </a:rPr>
-              <a:t>Both packages are public, so the cluster pulls them anonymously. A running pod’s image tag points straight back to the commit that built it, and no image is ever tagged latest.</a:t>
+              <a:t>argocd/datadrift-application.yaml points Argo CD at helm/datadrift and values-gitops.yaml.</a:t>
             </a:r>
             <a:endParaRPr lang="en-US" sz="1400" dirty="0"/>
           </a:p>
@@ -10906,7 +11876,7 @@
       </p:sp>
       <p:pic>
         <p:nvPicPr>
-          <p:cNvPr id="26" name="36-ghcr-backend-package.png" descr="36-ghcr-backend-package.png"/>
+          <p:cNvPr id="30" name="icon Application = chart + values" descr="image.png"/>
           <p:cNvPicPr>
             <a:picLocks noChangeAspect="1"/>
           </p:cNvPicPr>
@@ -10920,17 +11890,118 @@
         </p:blipFill>
         <p:spPr>
           <a:xfrm>
-            <a:off x="612647" y="1709928"/>
-            <a:ext cx="5413248" cy="3247382"/>
+            <a:off x="676656" y="3054096"/>
+            <a:ext cx="256032" cy="256032"/>
           </a:xfrm>
           <a:prstGeom prst="rect">
             <a:avLst/>
           </a:prstGeom>
         </p:spPr>
       </p:pic>
+      <p:sp>
+        <p:nvSpPr>
+          <p:cNvPr id="30" name="icon circle Gates in order"/>
+          <p:cNvSpPr/>
+          <p:nvPr/>
+        </p:nvSpPr>
+        <p:spPr>
+          <a:xfrm>
+            <a:off x="548640" y="4160520"/>
+            <a:ext cx="512064" cy="512064"/>
+          </a:xfrm>
+          <a:prstGeom prst="ellipse">
+            <a:avLst/>
+          </a:prstGeom>
+          <a:solidFill>
+            <a:schemeClr val="accent3"/>
+          </a:solidFill>
+          <a:ln w="12700">
+            <a:solidFill>
+              <a:schemeClr val="accent3"/>
+            </a:solidFill>
+            <a:prstDash val="solid"/>
+          </a:ln>
+        </p:spPr>
+        <p:txBody>
+          <a:bodyPr/>
+          <a:p/>
+        </p:txBody>
+      </p:sp>
+      <p:sp>
+        <p:nvSpPr>
+          <p:cNvPr id="32" name="Text 27"/>
+          <p:cNvSpPr txBox="1"/>
+          <p:nvPr/>
+        </p:nvSpPr>
+        <p:spPr>
+          <a:xfrm>
+            <a:off x="1261872" y="4142232"/>
+            <a:ext cx="5047488" cy="329184"/>
+          </a:xfrm>
+          <a:prstGeom prst="rect">
+            <a:avLst/>
+          </a:prstGeom>
+          <a:noFill/>
+          <a:ln/>
+        </p:spPr>
+        <p:txBody>
+          <a:bodyPr wrap="square" lIns="0" tIns="0" rIns="0" bIns="0" rtlCol="0" anchor="t"/>
+          <a:lstStyle/>
+          <a:p>
+            <a:pPr indent="0" marL="0">
+              <a:buNone/>
+            </a:pPr>
+            <a:r>
+              <a:rPr lang="en-US" sz="1700" b="1" dirty="0">
+                <a:solidFill>
+                  <a:schemeClr val="tx1"/>
+                </a:solidFill>
+              </a:rPr>
+              <a:t>Automated, self-healing sync</a:t>
+            </a:r>
+            <a:endParaRPr lang="en-US" sz="1700" dirty="0"/>
+          </a:p>
+        </p:txBody>
+      </p:sp>
+      <p:sp>
+        <p:nvSpPr>
+          <p:cNvPr id="33" name="Text 28"/>
+          <p:cNvSpPr txBox="1"/>
+          <p:nvPr/>
+        </p:nvSpPr>
+        <p:spPr>
+          <a:xfrm>
+            <a:off x="1261872" y="4489704"/>
+            <a:ext cx="5047488" cy="749808"/>
+          </a:xfrm>
+          <a:prstGeom prst="rect">
+            <a:avLst/>
+          </a:prstGeom>
+          <a:noFill/>
+          <a:ln/>
+        </p:spPr>
+        <p:txBody>
+          <a:bodyPr wrap="square" lIns="0" tIns="0" rIns="0" bIns="0" rtlCol="0" anchor="t"/>
+          <a:lstStyle/>
+          <a:p>
+            <a:pPr indent="0" marL="0">
+              <a:buNone/>
+            </a:pPr>
+            <a:r>
+              <a:rPr lang="en-US" sz="1400" dirty="0">
+                <a:solidFill>
+                  <a:schemeClr val="tx2"/>
+                </a:solidFill>
+              </a:rPr>
+              <a:t>prune removes objects deleted from Git; selfHeal undoes manual kubectl changes.</a:t>
+            </a:r>
+            <a:endParaRPr lang="en-US" sz="1400" dirty="0"/>
+          </a:p>
+        </p:txBody>
+      </p:sp>
       <p:pic>
         <p:nvPicPr>
-          <p:cNvPr id="27" name="37-ghcr-frontend-package.png" descr="37-ghcr-frontend-package.png"/>
+          <p:cNvPr id="34" name="icon Automated, self-healing sync" descr="image.png"/>
           <p:cNvPicPr>
             <a:picLocks noChangeAspect="1"/>
           </p:cNvPicPr>
@@ -10944,14 +12015,306 @@
         </p:blipFill>
         <p:spPr>
           <a:xfrm>
-            <a:off x="6165799" y="1709928"/>
-            <a:ext cx="5413248" cy="3250207"/>
+            <a:off x="676656" y="4288536"/>
+            <a:ext cx="256032" cy="256032"/>
           </a:xfrm>
           <a:prstGeom prst="rect">
             <a:avLst/>
           </a:prstGeom>
         </p:spPr>
       </p:pic>
+      <p:sp>
+        <p:nvSpPr>
+          <p:cNvPr id="14" name="icon circle ServiceMonitor"/>
+          <p:cNvSpPr/>
+          <p:nvPr/>
+        </p:nvSpPr>
+        <p:spPr>
+          <a:xfrm>
+            <a:off x="548640" y="5394960"/>
+            <a:ext cx="512064" cy="512064"/>
+          </a:xfrm>
+          <a:prstGeom prst="ellipse">
+            <a:avLst/>
+          </a:prstGeom>
+          <a:solidFill>
+            <a:schemeClr val="accent1"/>
+          </a:solidFill>
+          <a:ln w="12700">
+            <a:solidFill>
+              <a:schemeClr val="accent1"/>
+            </a:solidFill>
+            <a:prstDash val="solid"/>
+          </a:ln>
+        </p:spPr>
+        <p:txBody>
+          <a:bodyPr/>
+          <a:p/>
+        </p:txBody>
+      </p:sp>
+      <p:sp>
+        <p:nvSpPr>
+          <p:cNvPr id="16" name="Text 10"/>
+          <p:cNvSpPr txBox="1"/>
+          <p:nvPr/>
+        </p:nvSpPr>
+        <p:spPr>
+          <a:xfrm>
+            <a:off x="1261872" y="5376672"/>
+            <a:ext cx="5047488" cy="329184"/>
+          </a:xfrm>
+          <a:prstGeom prst="rect">
+            <a:avLst/>
+          </a:prstGeom>
+          <a:noFill/>
+          <a:ln/>
+        </p:spPr>
+        <p:txBody>
+          <a:bodyPr wrap="square" lIns="0" tIns="0" rIns="0" bIns="0" rtlCol="0" anchor="t"/>
+          <a:lstStyle/>
+          <a:p>
+            <a:pPr indent="0" marL="0">
+              <a:buNone/>
+            </a:pPr>
+            <a:r>
+              <a:rPr lang="en-US" sz="1700" b="1" dirty="0">
+                <a:solidFill>
+                  <a:schemeClr val="tx1"/>
+                </a:solidFill>
+              </a:rPr>
+              <a:t>Rollback is a git revert</a:t>
+            </a:r>
+            <a:endParaRPr lang="en-US" sz="1700" dirty="0"/>
+          </a:p>
+        </p:txBody>
+      </p:sp>
+      <p:sp>
+        <p:nvSpPr>
+          <p:cNvPr id="17" name="Text 11"/>
+          <p:cNvSpPr txBox="1"/>
+          <p:nvPr/>
+        </p:nvSpPr>
+        <p:spPr>
+          <a:xfrm>
+            <a:off x="1261872" y="5724144"/>
+            <a:ext cx="5047488" cy="749808"/>
+          </a:xfrm>
+          <a:prstGeom prst="rect">
+            <a:avLst/>
+          </a:prstGeom>
+          <a:noFill/>
+          <a:ln/>
+        </p:spPr>
+        <p:txBody>
+          <a:bodyPr wrap="square" lIns="0" tIns="0" rIns="0" bIns="0" rtlCol="0" anchor="t"/>
+          <a:lstStyle/>
+          <a:p>
+            <a:pPr indent="0" marL="0">
+              <a:buNone/>
+            </a:pPr>
+            <a:r>
+              <a:rPr lang="en-US" sz="1400" dirty="0">
+                <a:solidFill>
+                  <a:schemeClr val="tx2"/>
+                </a:solidFill>
+              </a:rPr>
+              <a:t>Reverting the tag commit puts the previous image back. Every release is in Git history.</a:t>
+            </a:r>
+            <a:endParaRPr lang="en-US" sz="1400" dirty="0"/>
+          </a:p>
+        </p:txBody>
+      </p:sp>
+      <p:pic>
+        <p:nvPicPr>
+          <p:cNvPr id="35" name="icon Rollback is a git revert" descr="image.png"/>
+          <p:cNvPicPr>
+            <a:picLocks noChangeAspect="1"/>
+          </p:cNvPicPr>
+          <p:nvPr/>
+        </p:nvPicPr>
+        <p:blipFill>
+          <a:blip r:embed="rId4"/>
+          <a:stretch>
+            <a:fillRect/>
+          </a:stretch>
+        </p:blipFill>
+        <p:spPr>
+          <a:xfrm>
+            <a:off x="676656" y="5522976"/>
+            <a:ext cx="256032" cy="256032"/>
+          </a:xfrm>
+          <a:prstGeom prst="rect">
+            <a:avLst/>
+          </a:prstGeom>
+        </p:spPr>
+      </p:pic>
+      <p:sp>
+        <p:nvSpPr>
+          <p:cNvPr id="36" name="values-gitops card"/>
+          <p:cNvSpPr/>
+          <p:nvPr/>
+        </p:nvSpPr>
+        <p:spPr>
+          <a:xfrm>
+            <a:off x="6675120" y="2926080"/>
+            <a:ext cx="4965192" cy="3017520"/>
+          </a:xfrm>
+          <a:prstGeom prst="roundRect">
+            <a:avLst>
+              <a:gd name="adj" fmla="val 5000"/>
+            </a:avLst>
+          </a:prstGeom>
+          <a:solidFill>
+            <a:srgbClr val="1E1B4B"/>
+          </a:solidFill>
+          <a:ln>
+            <a:noFill/>
+          </a:ln>
+        </p:spPr>
+        <p:style>
+          <a:lnRef idx="1">
+            <a:schemeClr val="accent1"/>
+          </a:lnRef>
+          <a:fillRef idx="3">
+            <a:schemeClr val="accent1"/>
+          </a:fillRef>
+          <a:effectRef idx="2">
+            <a:schemeClr val="accent1"/>
+          </a:effectRef>
+          <a:fontRef idx="minor">
+            <a:schemeClr val="lt1"/>
+          </a:fontRef>
+        </p:style>
+        <p:txBody>
+          <a:bodyPr rtlCol="0" anchor="ctr"/>
+          <a:lstStyle/>
+          <a:p>
+            <a:pPr algn="ctr"/>
+          </a:p>
+        </p:txBody>
+      </p:sp>
+      <p:sp>
+        <p:nvSpPr>
+          <p:cNvPr id="37" name="values-gitops snippet"/>
+          <p:cNvSpPr txBox="1"/>
+          <p:nvPr/>
+        </p:nvSpPr>
+        <p:spPr>
+          <a:xfrm>
+            <a:off x="6949440" y="3108960"/>
+            <a:ext cx="4480560" cy="2651760"/>
+          </a:xfrm>
+          <a:prstGeom prst="rect">
+            <a:avLst/>
+          </a:prstGeom>
+          <a:noFill/>
+        </p:spPr>
+        <p:txBody>
+          <a:bodyPr wrap="square" anchor="t">
+            <a:spAutoFit/>
+          </a:bodyPr>
+          <a:lstStyle/>
+          <a:p>
+            <a:r>
+              <a:rPr sz="1400">
+                <a:solidFill>
+                  <a:srgbClr val="A5B4FC"/>
+                </a:solidFill>
+                <a:latin typeface="Courier New"/>
+              </a:rPr>
+              <a:t># helm/datadrift/values-gitops.yaml</a:t>
+            </a:r>
+          </a:p>
+          <a:p>
+            <a:r>
+              <a:rPr sz="1400">
+                <a:solidFill>
+                  <a:srgbClr val="FFFFFF"/>
+                </a:solidFill>
+                <a:latin typeface="Courier New"/>
+              </a:rPr>
+              <a:t>backend:</a:t>
+            </a:r>
+          </a:p>
+          <a:p>
+            <a:r>
+              <a:rPr sz="1400">
+                <a:solidFill>
+                  <a:srgbClr val="FFFFFF"/>
+                </a:solidFill>
+                <a:latin typeface="Courier New"/>
+              </a:rPr>
+              <a:t>  image:</a:t>
+            </a:r>
+          </a:p>
+          <a:p>
+            <a:r>
+              <a:rPr sz="1400">
+                <a:solidFill>
+                  <a:srgbClr val="FFFFFF"/>
+                </a:solidFill>
+                <a:latin typeface="Courier New"/>
+              </a:rPr>
+              <a:t>    repository: ghcr.io/kavyadhyani/</a:t>
+            </a:r>
+          </a:p>
+          <a:p>
+            <a:r>
+              <a:rPr sz="1400">
+                <a:solidFill>
+                  <a:srgbClr val="FFFFFF"/>
+                </a:solidFill>
+                <a:latin typeface="Courier New"/>
+              </a:rPr>
+              <a:t>                datadrift-backend</a:t>
+            </a:r>
+          </a:p>
+          <a:p>
+            <a:r>
+              <a:rPr sz="1400">
+                <a:solidFill>
+                  <a:srgbClr val="6EE7B7"/>
+                </a:solidFill>
+                <a:latin typeface="Courier New"/>
+              </a:rPr>
+              <a:t>    tag: 769f97f…   # written by CI</a:t>
+            </a:r>
+          </a:p>
+          <a:p>
+            <a:r>
+              <a:rPr sz="1400">
+                <a:solidFill>
+                  <a:srgbClr val="FFFFFF"/>
+                </a:solidFill>
+                <a:latin typeface="Courier New"/>
+              </a:rPr>
+              <a:t>frontend:</a:t>
+            </a:r>
+          </a:p>
+          <a:p>
+            <a:r>
+              <a:rPr sz="1400">
+                <a:solidFill>
+                  <a:srgbClr val="FFFFFF"/>
+                </a:solidFill>
+                <a:latin typeface="Courier New"/>
+              </a:rPr>
+              <a:t>  image:</a:t>
+            </a:r>
+          </a:p>
+          <a:p>
+            <a:r>
+              <a:rPr sz="1400">
+                <a:solidFill>
+                  <a:srgbClr val="6EE7B7"/>
+                </a:solidFill>
+                <a:latin typeface="Courier New"/>
+              </a:rPr>
+              <a:t>    tag: 769f97f…   # same commit</a:t>
+            </a:r>
+          </a:p>
+        </p:txBody>
+      </p:sp>
     </p:spTree>
   </p:cSld>
   <p:clrMapOvr>
@@ -11086,6 +12449,10 @@
             </a:outerShdw>
           </a:effectLst>
         </p:spPr>
+        <p:txBody>
+          <a:bodyPr/>
+          <a:p/>
+        </p:txBody>
       </p:sp>
       <p:sp>
         <p:nvSpPr>
@@ -11170,6 +12537,10 @@
             </a:outerShdw>
           </a:effectLst>
         </p:spPr>
+        <p:txBody>
+          <a:bodyPr/>
+          <a:p/>
+        </p:txBody>
       </p:sp>
       <p:sp>
         <p:nvSpPr>
@@ -11254,6 +12625,10 @@
             </a:outerShdw>
           </a:effectLst>
         </p:spPr>
+        <p:txBody>
+          <a:bodyPr/>
+          <a:p/>
+        </p:txBody>
       </p:sp>
       <p:sp>
         <p:nvSpPr>
@@ -11338,6 +12713,10 @@
             </a:outerShdw>
           </a:effectLst>
         </p:spPr>
+        <p:txBody>
+          <a:bodyPr/>
+          <a:p/>
+        </p:txBody>
       </p:sp>
       <p:sp>
         <p:nvSpPr>
@@ -11422,6 +12801,10 @@
             </a:outerShdw>
           </a:effectLst>
         </p:spPr>
+        <p:txBody>
+          <a:bodyPr/>
+          <a:p/>
+        </p:txBody>
       </p:sp>
       <p:sp>
         <p:nvSpPr>
@@ -11453,7 +12836,7 @@
                   <a:schemeClr val="bg1"/>
                 </a:solidFill>
               </a:rPr>
-              <a:t>Helm</a:t>
+              <a:t>Argo CD</a:t>
             </a:r>
             <a:endParaRPr lang="en-US" sz="1500" dirty="0"/>
           </a:p>
@@ -11467,7 +12850,7 @@
                   <a:schemeClr val="bg1"/>
                 </a:solidFill>
               </a:rPr>
-              <a:t>upgrade --install</a:t>
+              <a:t>syncs the Helm chart</a:t>
             </a:r>
             <a:endParaRPr lang="en-US" sz="1500" dirty="0"/>
           </a:p>
@@ -11496,6 +12879,10 @@
             <a:tailEnd type="triangle"/>
           </a:ln>
         </p:spPr>
+        <p:txBody>
+          <a:bodyPr/>
+          <a:p/>
+        </p:txBody>
       </p:sp>
       <p:sp>
         <p:nvSpPr>
@@ -11520,6 +12907,10 @@
             <a:tailEnd type="triangle"/>
           </a:ln>
         </p:spPr>
+        <p:txBody>
+          <a:bodyPr/>
+          <a:p/>
+        </p:txBody>
       </p:sp>
       <p:sp>
         <p:nvSpPr>
@@ -11544,6 +12935,10 @@
             <a:tailEnd type="triangle"/>
           </a:ln>
         </p:spPr>
+        <p:txBody>
+          <a:bodyPr/>
+          <a:p/>
+        </p:txBody>
       </p:sp>
       <p:sp>
         <p:nvSpPr>
@@ -11568,6 +12963,10 @@
             <a:tailEnd type="triangle"/>
           </a:ln>
         </p:spPr>
+        <p:txBody>
+          <a:bodyPr/>
+          <a:p/>
+        </p:txBody>
       </p:sp>
       <p:sp>
         <p:nvSpPr>
@@ -11595,6 +12994,10 @@
             <a:prstDash val="dash"/>
           </a:ln>
         </p:spPr>
+        <p:txBody>
+          <a:bodyPr/>
+          <a:p/>
+        </p:txBody>
       </p:sp>
       <p:sp>
         <p:nvSpPr>
@@ -11665,6 +13068,10 @@
             </a:outerShdw>
           </a:effectLst>
         </p:spPr>
+        <p:txBody>
+          <a:bodyPr/>
+          <a:p/>
+        </p:txBody>
       </p:sp>
       <p:sp>
         <p:nvSpPr>
@@ -11749,6 +13156,10 @@
             </a:outerShdw>
           </a:effectLst>
         </p:spPr>
+        <p:txBody>
+          <a:bodyPr/>
+          <a:p/>
+        </p:txBody>
       </p:sp>
       <p:sp>
         <p:nvSpPr>
@@ -11833,6 +13244,10 @@
             </a:outerShdw>
           </a:effectLst>
         </p:spPr>
+        <p:txBody>
+          <a:bodyPr/>
+          <a:p/>
+        </p:txBody>
       </p:sp>
       <p:sp>
         <p:nvSpPr>
@@ -11917,6 +13332,10 @@
             </a:outerShdw>
           </a:effectLst>
         </p:spPr>
+        <p:txBody>
+          <a:bodyPr/>
+          <a:p/>
+        </p:txBody>
       </p:sp>
       <p:sp>
         <p:nvSpPr>
@@ -11991,6 +13410,10 @@
             <a:tailEnd type="triangle"/>
           </a:ln>
         </p:spPr>
+        <p:txBody>
+          <a:bodyPr/>
+          <a:p/>
+        </p:txBody>
       </p:sp>
       <p:sp>
         <p:nvSpPr>
@@ -12015,6 +13438,10 @@
             <a:tailEnd type="triangle"/>
           </a:ln>
         </p:spPr>
+        <p:txBody>
+          <a:bodyPr/>
+          <a:p/>
+        </p:txBody>
       </p:sp>
       <p:sp>
         <p:nvSpPr>
@@ -12038,6 +13465,10 @@
             <a:prstDash val="solid"/>
           </a:ln>
         </p:spPr>
+        <p:txBody>
+          <a:bodyPr/>
+          <a:p/>
+        </p:txBody>
       </p:sp>
       <p:sp>
         <p:nvSpPr>
@@ -12134,6 +13565,10 @@
             <a:tailEnd type="triangle"/>
           </a:ln>
         </p:spPr>
+        <p:txBody>
+          <a:bodyPr/>
+          <a:p/>
+        </p:txBody>
       </p:sp>
       <p:sp>
         <p:nvSpPr>
@@ -12161,6 +13596,10 @@
             <a:prstDash val="dash"/>
           </a:ln>
         </p:spPr>
+        <p:txBody>
+          <a:bodyPr/>
+          <a:p/>
+        </p:txBody>
       </p:sp>
       <p:sp>
         <p:nvSpPr>
@@ -12231,6 +13670,10 @@
             </a:outerShdw>
           </a:effectLst>
         </p:spPr>
+        <p:txBody>
+          <a:bodyPr/>
+          <a:p/>
+        </p:txBody>
       </p:sp>
       <p:sp>
         <p:nvSpPr>
@@ -12315,6 +13758,10 @@
             </a:outerShdw>
           </a:effectLst>
         </p:spPr>
+        <p:txBody>
+          <a:bodyPr/>
+          <a:p/>
+        </p:txBody>
       </p:sp>
       <p:sp>
         <p:nvSpPr>
@@ -12389,6 +13836,10 @@
             <a:tailEnd type="triangle"/>
           </a:ln>
         </p:spPr>
+        <p:txBody>
+          <a:bodyPr/>
+          <a:p/>
+        </p:txBody>
       </p:sp>
       <p:sp>
         <p:nvSpPr>
@@ -12412,6 +13863,10 @@
             <a:prstDash val="solid"/>
           </a:ln>
         </p:spPr>
+        <p:txBody>
+          <a:bodyPr/>
+          <a:p/>
+        </p:txBody>
       </p:sp>
       <p:sp>
         <p:nvSpPr>
@@ -12435,6 +13890,10 @@
             <a:prstDash val="solid"/>
           </a:ln>
         </p:spPr>
+        <p:txBody>
+          <a:bodyPr/>
+          <a:p/>
+        </p:txBody>
       </p:sp>
       <p:sp>
         <p:nvSpPr>
@@ -12458,6 +13917,10 @@
             <a:prstDash val="solid"/>
           </a:ln>
         </p:spPr>
+        <p:txBody>
+          <a:bodyPr/>
+          <a:p/>
+        </p:txBody>
       </p:sp>
       <p:sp>
         <p:nvSpPr>
@@ -12482,6 +13945,10 @@
             <a:tailEnd type="triangle"/>
           </a:ln>
         </p:spPr>
+        <p:txBody>
+          <a:bodyPr/>
+          <a:p/>
+        </p:txBody>
       </p:sp>
       <p:sp>
         <p:nvSpPr>
@@ -12541,6 +14008,10 @@
             <a:prstDash val="solid"/>
           </a:ln>
         </p:spPr>
+        <p:txBody>
+          <a:bodyPr/>
+          <a:p/>
+        </p:txBody>
       </p:sp>
       <p:sp>
         <p:nvSpPr>
@@ -12564,6 +14035,10 @@
             <a:prstDash val="solid"/>
           </a:ln>
         </p:spPr>
+        <p:txBody>
+          <a:bodyPr/>
+          <a:p/>
+        </p:txBody>
       </p:sp>
       <p:sp>
         <p:nvSpPr>
@@ -12588,6 +14063,10 @@
             <a:tailEnd type="triangle"/>
           </a:ln>
         </p:spPr>
+        <p:txBody>
+          <a:bodyPr/>
+          <a:p/>
+        </p:txBody>
       </p:sp>
       <p:sp>
         <p:nvSpPr>
@@ -12619,7 +14098,7 @@
                   <a:schemeClr val="accent6"/>
                 </a:solidFill>
               </a:rPr>
-              <a:t>deploys</a:t>
+              <a:t>GitOps</a:t>
             </a:r>
             <a:endParaRPr lang="en-US" sz="1200" dirty="0"/>
           </a:p>
@@ -13306,7 +14785,7 @@
                           <a:ea typeface="Calibri" pitchFamily="34" charset="-122"/>
                           <a:cs typeface="Calibri" pitchFamily="34" charset="-120"/>
                         </a:rPr>
-                        <a:t>Public repository, 23 descriptive commits, .gitignore for secrets and build output</a:t>
+                        <a:t>Public repository, 30+ descriptive commits, .gitignore for secrets and build output</a:t>
                       </a:r>
                       <a:endParaRPr lang="en-US" sz="1400" dirty="0">
                         <a:latin typeface="Calibri" charset="0"/>
@@ -13574,7 +15053,7 @@
                           <a:ea typeface="Calibri" pitchFamily="34" charset="-122"/>
                           <a:cs typeface="Calibri" pitchFamily="34" charset="-120"/>
                         </a:rPr>
-                        <a:t>GitHub Actions: test → build → scan → push to GHCR with SHA tags → Helm deploy</a:t>
+                        <a:t>GitHub Actions: test → build → scan → push to GHCR with SHA tags → GitOps tag bump</a:t>
                       </a:r>
                       <a:endParaRPr lang="en-US" sz="1400" dirty="0">
                         <a:latin typeface="Calibri" charset="0"/>
@@ -13976,7 +15455,7 @@
                           <a:ea typeface="Calibri" pitchFamily="34" charset="-122"/>
                           <a:cs typeface="Calibri" pitchFamily="34" charset="-120"/>
                         </a:rPr>
-                        <a:t>Helm chart: Deployments, StatefulSet, Services, Ingress, HPA</a:t>
+                        <a:t>Helm chart deployed by Argo CD (GitOps): Deployments, StatefulSet, Services, Ingress, HPA</a:t>
                       </a:r>
                       <a:endParaRPr lang="en-US" sz="1400" dirty="0">
                         <a:latin typeface="Calibri" charset="0"/>
@@ -14244,7 +15723,7 @@
                           <a:ea typeface="Calibri" pitchFamily="34" charset="-122"/>
                           <a:cs typeface="Calibri" pitchFamily="34" charset="-120"/>
                         </a:rPr>
-                        <a:t>README with screenshots, live commit → pipeline → rollout</a:t>
+                        <a:t>README, plus slides and video in demo/; live push → pipeline → Argo CD rollout</a:t>
                       </a:r>
                       <a:endParaRPr lang="en-US" sz="1400" dirty="0">
                         <a:latin typeface="Calibri" charset="0"/>
@@ -16897,6 +18376,10 @@
             <a:prstDash val="solid"/>
           </a:ln>
         </p:spPr>
+        <p:txBody>
+          <a:bodyPr/>
+          <a:p/>
+        </p:txBody>
       </p:sp>
       <p:sp>
         <p:nvSpPr>
@@ -16922,6 +18405,10 @@
             <a:prstDash val="solid"/>
           </a:ln>
         </p:spPr>
+        <p:txBody>
+          <a:bodyPr/>
+          <a:p/>
+        </p:txBody>
       </p:sp>
       <p:sp>
         <p:nvSpPr>
@@ -17035,6 +18522,10 @@
             <a:prstDash val="solid"/>
           </a:ln>
         </p:spPr>
+        <p:txBody>
+          <a:bodyPr/>
+          <a:p/>
+        </p:txBody>
       </p:sp>
       <p:sp>
         <p:nvSpPr>
@@ -17060,6 +18551,10 @@
             <a:prstDash val="solid"/>
           </a:ln>
         </p:spPr>
+        <p:txBody>
+          <a:bodyPr/>
+          <a:p/>
+        </p:txBody>
       </p:sp>
       <p:sp>
         <p:nvSpPr>
@@ -17173,6 +18668,10 @@
             <a:prstDash val="solid"/>
           </a:ln>
         </p:spPr>
+        <p:txBody>
+          <a:bodyPr/>
+          <a:p/>
+        </p:txBody>
       </p:sp>
       <p:sp>
         <p:nvSpPr>
@@ -17198,6 +18697,10 @@
             <a:prstDash val="solid"/>
           </a:ln>
         </p:spPr>
+        <p:txBody>
+          <a:bodyPr/>
+          <a:p/>
+        </p:txBody>
       </p:sp>
       <p:sp>
         <p:nvSpPr>
@@ -17311,6 +18814,10 @@
             <a:prstDash val="solid"/>
           </a:ln>
         </p:spPr>
+        <p:txBody>
+          <a:bodyPr/>
+          <a:p/>
+        </p:txBody>
       </p:sp>
       <p:sp>
         <p:nvSpPr>
@@ -17336,6 +18843,10 @@
             <a:prstDash val="solid"/>
           </a:ln>
         </p:spPr>
+        <p:txBody>
+          <a:bodyPr/>
+          <a:p/>
+        </p:txBody>
       </p:sp>
       <p:sp>
         <p:nvSpPr>
@@ -17449,6 +18960,10 @@
             <a:prstDash val="solid"/>
           </a:ln>
         </p:spPr>
+        <p:txBody>
+          <a:bodyPr/>
+          <a:p/>
+        </p:txBody>
       </p:sp>
       <p:sp>
         <p:nvSpPr>
@@ -17474,6 +18989,10 @@
             <a:prstDash val="solid"/>
           </a:ln>
         </p:spPr>
+        <p:txBody>
+          <a:bodyPr/>
+          <a:p/>
+        </p:txBody>
       </p:sp>
       <p:sp>
         <p:nvSpPr>
@@ -17541,7 +19060,7 @@
                   <a:schemeClr val="tx1"/>
                 </a:solidFill>
               </a:rPr>
-              <a:t>Deploy</a:t>
+              <a:t>GitOps</a:t>
             </a:r>
             <a:endParaRPr lang="en-US" sz="1500" dirty="0"/>
           </a:p>
@@ -17555,7 +19074,7 @@
                   <a:schemeClr val="tx1"/>
                 </a:solidFill>
               </a:rPr>
-              <a:t>helm upgrade</a:t>
+              <a:t>tag → Argo CD</a:t>
             </a:r>
             <a:endParaRPr lang="en-US" sz="1500" dirty="0"/>
           </a:p>
@@ -17594,6 +19113,10 @@
             </a:outerShdw>
           </a:effectLst>
         </p:spPr>
+        <p:txBody>
+          <a:bodyPr/>
+          <a:p/>
+        </p:txBody>
       </p:sp>
       <p:pic>
         <p:nvPicPr>
@@ -17643,6 +19166,10 @@
             <a:prstDash val="solid"/>
           </a:ln>
         </p:spPr>
+        <p:txBody>
+          <a:bodyPr/>
+          <a:p/>
+        </p:txBody>
       </p:sp>
       <p:pic>
         <p:nvPicPr>
@@ -17764,6 +19291,10 @@
             <a:prstDash val="solid"/>
           </a:ln>
         </p:spPr>
+        <p:txBody>
+          <a:bodyPr/>
+          <a:p/>
+        </p:txBody>
       </p:sp>
       <p:pic>
         <p:nvPicPr>
@@ -17885,6 +19416,10 @@
             <a:prstDash val="solid"/>
           </a:ln>
         </p:spPr>
+        <p:txBody>
+          <a:bodyPr/>
+          <a:p/>
+        </p:txBody>
       </p:sp>
       <p:pic>
         <p:nvPicPr>
@@ -17940,7 +19475,7 @@
                   <a:schemeClr val="tx1"/>
                 </a:solidFill>
               </a:rPr>
-              <a:t>Deploy when a cluster exists</a:t>
+              <a:t>Hand-off to Argo CD</a:t>
             </a:r>
             <a:endParaRPr lang="en-US" sz="1700" dirty="0"/>
           </a:p>
@@ -17976,7 +19511,7 @@
                   <a:schemeClr val="tx2"/>
                 </a:solidFill>
               </a:rPr>
-              <a:t>Runs helm upgrade when a KUBE_CONFIG_DATA secret is set.</a:t>
+              <a:t>The last job commits the new SHA to values-gitops.yaml; Argo CD deploys it.</a:t>
             </a:r>
             <a:endParaRPr lang="en-US" sz="1400" dirty="0"/>
           </a:p>

</xml_diff>